<commit_message>
Add verified GasFree Nile canary evidence
</commit_message>
<xml_diff>
--- a/docs/submission/pitch-deck.pptx
+++ b/docs/submission/pitch-deck.pptx
@@ -2,19 +2,19 @@
 <file path=ppt/presentation.xml><?xml version="1.0" encoding="utf-8"?>
 <p:presentation xmlns:p="http://schemas.openxmlformats.org/presentationml/2006/main">
   <p:sldMasterIdLst>
-    <p:sldMasterId xmlns:r="http://schemas.openxmlformats.org/officeDocument/2006/relationships" id="2147483648" r:id="R1953fbf626bc4b1e"/>
+    <p:sldMasterId xmlns:r="http://schemas.openxmlformats.org/officeDocument/2006/relationships" id="2147483648" r:id="R35276eab1d364022"/>
   </p:sldMasterIdLst>
   <p:notesMasterIdLst>
-    <p:notesMasterId xmlns:r="http://schemas.openxmlformats.org/officeDocument/2006/relationships" r:id="R22481aa00ce4472c"/>
+    <p:notesMasterId xmlns:r="http://schemas.openxmlformats.org/officeDocument/2006/relationships" r:id="Rf984c0bc08e247eb"/>
   </p:notesMasterIdLst>
   <p:sldIdLst>
-    <p:sldId xmlns:r="http://schemas.openxmlformats.org/officeDocument/2006/relationships" id="256" r:id="R270da1d7a97a48cd"/>
-    <p:sldId xmlns:r="http://schemas.openxmlformats.org/officeDocument/2006/relationships" id="257" r:id="R197aa142e1f9436e"/>
-    <p:sldId xmlns:r="http://schemas.openxmlformats.org/officeDocument/2006/relationships" id="258" r:id="Rac85db40cbc44db9"/>
-    <p:sldId xmlns:r="http://schemas.openxmlformats.org/officeDocument/2006/relationships" id="259" r:id="Re412682ba8894399"/>
-    <p:sldId xmlns:r="http://schemas.openxmlformats.org/officeDocument/2006/relationships" id="260" r:id="R35c1c8884a8a404e"/>
-    <p:sldId xmlns:r="http://schemas.openxmlformats.org/officeDocument/2006/relationships" id="261" r:id="R0bf6be4575e243b7"/>
-    <p:sldId xmlns:r="http://schemas.openxmlformats.org/officeDocument/2006/relationships" id="262" r:id="R2d5248a8e1f14717"/>
+    <p:sldId xmlns:r="http://schemas.openxmlformats.org/officeDocument/2006/relationships" id="256" r:id="R045ffc5395424e8a"/>
+    <p:sldId xmlns:r="http://schemas.openxmlformats.org/officeDocument/2006/relationships" id="257" r:id="R05020eb6a5db4441"/>
+    <p:sldId xmlns:r="http://schemas.openxmlformats.org/officeDocument/2006/relationships" id="258" r:id="Rdc911dcf7f8546bb"/>
+    <p:sldId xmlns:r="http://schemas.openxmlformats.org/officeDocument/2006/relationships" id="259" r:id="R580ed13e77c5443d"/>
+    <p:sldId xmlns:r="http://schemas.openxmlformats.org/officeDocument/2006/relationships" id="260" r:id="R531dfa7aa9be4ca9"/>
+    <p:sldId xmlns:r="http://schemas.openxmlformats.org/officeDocument/2006/relationships" id="261" r:id="R369394d8fd0a4c8f"/>
+    <p:sldId xmlns:r="http://schemas.openxmlformats.org/officeDocument/2006/relationships" id="262" r:id="R5c0a115a3d674271"/>
   </p:sldIdLst>
   <p:sldSz cx="12192000" cy="6858000"/>
   <p:notesSz cx="6858000" cy="9144000"/>
@@ -453,17 +453,47 @@
           </a:p>
           <a:p xmlns:a="http://schemas.openxmlformats.org/drawingml/2006/main">
             <a:r>
-              <a:t>Repository sources: projects/tron-c/README.md; projects/tron-c/docs/verification.md; projects/tron-c/server/README.md.</a:t>
-            </a:r>
-          </a:p>
-          <a:p xmlns:a="http://schemas.openxmlformats.org/drawingml/2006/main">
-            <a:r>
-              <a:t>Official GasFree integration references are linked from the repository README.</a:t>
-            </a:r>
-          </a:p>
-          <a:p xmlns:a="http://schemas.openxmlformats.org/drawingml/2006/main">
-            <a:r>
-              <a:t>Transaction link: unavailable — no GasFree credentials, traceId or verified Nile transaction exists yet.</a:t>
+              <a:t>Repository sources: projects/tron-c/docs/gasfree-one-shot.md; projects/tron-c/server/integration/README.md; sanitized canary evidence at submissions/gwdc-2026-settlemap/.data/gasfree-one-shot/gwdc-final-20260930-001.evidence.json.</a:t>
+            </a:r>
+          </a:p>
+          <a:p xmlns:a="http://schemas.openxmlformats.org/drawingml/2006/main">
+            <a:r>
+              <a:t>Verified Nile canary transaction: https://nile.tronscan.org/#/transaction/1f3a3de905eeef90570bf297bb592d4ac16383a5a10c1187c4e09b41b5fdd586</a:t>
+            </a:r>
+          </a:p>
+          <a:p xmlns:a="http://schemas.openxmlformats.org/drawingml/2006/main">
+            <a:r>
+              <a:t>Canary result: provider SUCCEED; chain SOLIDITY; block 71389721; exact TRC-20 Transfer at log index 2.</a:t>
+            </a:r>
+          </a:p>
+          <a:p xmlns:a="http://schemas.openxmlformats.org/drawingml/2006/main">
+            <a:r>
+              <a:t>Transfer: 1.000001 USDT from derived GasFree account TH3V9cnUct542ss5ZgAzNHWnFH9ycB1Tw1 to dedicated EOA TQcxtc1CmGRL8NwuDs3LewTBFycgXb28AR. Actual fee: 1.3 USDT.</a:t>
+            </a:r>
+          </a:p>
+          <a:p xmlns:a="http://schemas.openxmlformats.org/drawingml/2006/main">
+            <a:r>
+              <a:t>Verification source: GasFree provider status + Nile Solidity RPC.</a:t>
+            </a:r>
+          </a:p>
+          <a:p xmlns:a="http://schemas.openxmlformats.org/drawingml/2006/main">
+            <a:r>
+              <a:t>GasFree API source: https://docs.gasfree.io/</a:t>
+            </a:r>
+          </a:p>
+          <a:p xmlns:a="http://schemas.openxmlformats.org/drawingml/2006/main">
+            <a:r>
+              <a:t>TRON Solidity confirmation source: https://developers.tron.network/docs/confirmation-semantics</a:t>
+            </a:r>
+          </a:p>
+          <a:p xmlns:a="http://schemas.openxmlformats.org/drawingml/2006/main">
+            <a:r>
+              <a:t>Nile Solidity receipt endpoint: https://nile.trongrid.io/walletsolidity/gettransactioninfobyid (POST)</a:t>
+            </a:r>
+          </a:p>
+          <a:p xmlns:a="http://schemas.openxmlformats.org/drawingml/2006/main">
+            <a:r>
+              <a:t>Scope boundary: this proves one recipient canary only, not the complete multi-recipient batch.</a:t>
             </a:r>
           </a:p>
           <a:p xmlns:a="http://schemas.openxmlformats.org/drawingml/2006/main">
@@ -543,32 +573,57 @@
           <a:lstStyle xmlns:a="http://schemas.openxmlformats.org/drawingml/2006/main"/>
           <a:p xmlns:a="http://schemas.openxmlformats.org/drawingml/2006/main">
             <a:r>
-              <a:t>Slide 2 — Product overview and current evidence boundary.</a:t>
-            </a:r>
-          </a:p>
-          <a:p xmlns:a="http://schemas.openxmlformats.org/drawingml/2006/main">
-            <a:r>
-              <a:t>Repository sources: projects/tron-c/README.md; projects/tron-c/docs/verification.md; projects/tron-c/server/README.md.</a:t>
-            </a:r>
-          </a:p>
-          <a:p xmlns:a="http://schemas.openxmlformats.org/drawingml/2006/main">
-            <a:r>
-              <a:t>Official GasFree integration references are linked from the repository README.</a:t>
-            </a:r>
-          </a:p>
-          <a:p xmlns:a="http://schemas.openxmlformats.org/drawingml/2006/main">
-            <a:r>
-              <a:t>Transaction link: unavailable — no GasFree credentials, traceId or verified Nile transaction exists yet.</a:t>
+              <a:t>Slide 2 — Product overview and verified canary scope.</a:t>
+            </a:r>
+          </a:p>
+          <a:p xmlns:a="http://schemas.openxmlformats.org/drawingml/2006/main">
+            <a:r>
+              <a:t>Repository sources: projects/tron-c/docs/gasfree-one-shot.md; projects/tron-c/server/integration/README.md; sanitized canary evidence at submissions/gwdc-2026-settlemap/.data/gasfree-one-shot/gwdc-final-20260930-001.evidence.json.</a:t>
+            </a:r>
+          </a:p>
+          <a:p xmlns:a="http://schemas.openxmlformats.org/drawingml/2006/main">
+            <a:r>
+              <a:t>Verified Nile canary transaction: https://nile.tronscan.org/#/transaction/1f3a3de905eeef90570bf297bb592d4ac16383a5a10c1187c4e09b41b5fdd586</a:t>
+            </a:r>
+          </a:p>
+          <a:p xmlns:a="http://schemas.openxmlformats.org/drawingml/2006/main">
+            <a:r>
+              <a:t>Canary result: provider SUCCEED; chain SOLIDITY; block 71389721; exact TRC-20 Transfer at log index 2.</a:t>
+            </a:r>
+          </a:p>
+          <a:p xmlns:a="http://schemas.openxmlformats.org/drawingml/2006/main">
+            <a:r>
+              <a:t>Transfer: 1.000001 USDT from derived GasFree account TH3V9cnUct542ss5ZgAzNHWnFH9ycB1Tw1 to dedicated EOA TQcxtc1CmGRL8NwuDs3LewTBFycgXb28AR. Actual fee: 1.3 USDT.</a:t>
+            </a:r>
+          </a:p>
+          <a:p xmlns:a="http://schemas.openxmlformats.org/drawingml/2006/main">
+            <a:r>
+              <a:t>Verification source: GasFree provider status + Nile Solidity RPC.</a:t>
+            </a:r>
+          </a:p>
+          <a:p xmlns:a="http://schemas.openxmlformats.org/drawingml/2006/main">
+            <a:r>
+              <a:t>GasFree API source: https://docs.gasfree.io/</a:t>
+            </a:r>
+          </a:p>
+          <a:p xmlns:a="http://schemas.openxmlformats.org/drawingml/2006/main">
+            <a:r>
+              <a:t>TRON Solidity confirmation source: https://developers.tron.network/docs/confirmation-semantics</a:t>
+            </a:r>
+          </a:p>
+          <a:p xmlns:a="http://schemas.openxmlformats.org/drawingml/2006/main">
+            <a:r>
+              <a:t>Nile Solidity receipt endpoint: https://nile.trongrid.io/walletsolidity/gettransactioninfobyid (POST)</a:t>
+            </a:r>
+          </a:p>
+          <a:p xmlns:a="http://schemas.openxmlformats.org/drawingml/2006/main">
+            <a:r>
+              <a:t>Scope boundary: this proves one recipient canary only, not the complete multi-recipient batch.</a:t>
             </a:r>
           </a:p>
           <a:p xmlns:a="http://schemas.openxmlformats.org/drawingml/2006/main">
             <a:r>
               <a:t>Screenshot: projects/tron-c/docs/creator-story-review.png</a:t>
-            </a:r>
-          </a:p>
-          <a:p xmlns:a="http://schemas.openxmlformats.org/drawingml/2006/main">
-            <a:r>
-              <a:t>Boundary: No real GasFree credentials, trace or transaction has been verified. Current execution evidence is fixture-only.</a:t>
             </a:r>
           </a:p>
           <a:p xmlns:a="http://schemas.openxmlformats.org/drawingml/2006/main">
@@ -648,22 +703,52 @@
           </a:p>
           <a:p xmlns:a="http://schemas.openxmlformats.org/drawingml/2006/main">
             <a:r>
-              <a:t>Repository sources: projects/tron-c/README.md; projects/tron-c/docs/verification.md; projects/tron-c/server/README.md.</a:t>
-            </a:r>
-          </a:p>
-          <a:p xmlns:a="http://schemas.openxmlformats.org/drawingml/2006/main">
-            <a:r>
-              <a:t>Official GasFree integration references are linked from the repository README.</a:t>
-            </a:r>
-          </a:p>
-          <a:p xmlns:a="http://schemas.openxmlformats.org/drawingml/2006/main">
-            <a:r>
-              <a:t>Transaction link: unavailable — no GasFree credentials, traceId or verified Nile transaction exists yet.</a:t>
-            </a:r>
-          </a:p>
-          <a:p xmlns:a="http://schemas.openxmlformats.org/drawingml/2006/main">
-            <a:r>
-              <a:t>Claims are product-scope statements derived from the repository README and verification record; no market-size estimate is asserted.</a:t>
+              <a:t>Repository sources: projects/tron-c/docs/gasfree-one-shot.md; projects/tron-c/server/integration/README.md; sanitized canary evidence at submissions/gwdc-2026-settlemap/.data/gasfree-one-shot/gwdc-final-20260930-001.evidence.json.</a:t>
+            </a:r>
+          </a:p>
+          <a:p xmlns:a="http://schemas.openxmlformats.org/drawingml/2006/main">
+            <a:r>
+              <a:t>Verified Nile canary transaction: https://nile.tronscan.org/#/transaction/1f3a3de905eeef90570bf297bb592d4ac16383a5a10c1187c4e09b41b5fdd586</a:t>
+            </a:r>
+          </a:p>
+          <a:p xmlns:a="http://schemas.openxmlformats.org/drawingml/2006/main">
+            <a:r>
+              <a:t>Canary result: provider SUCCEED; chain SOLIDITY; block 71389721; exact TRC-20 Transfer at log index 2.</a:t>
+            </a:r>
+          </a:p>
+          <a:p xmlns:a="http://schemas.openxmlformats.org/drawingml/2006/main">
+            <a:r>
+              <a:t>Transfer: 1.000001 USDT from derived GasFree account TH3V9cnUct542ss5ZgAzNHWnFH9ycB1Tw1 to dedicated EOA TQcxtc1CmGRL8NwuDs3LewTBFycgXb28AR. Actual fee: 1.3 USDT.</a:t>
+            </a:r>
+          </a:p>
+          <a:p xmlns:a="http://schemas.openxmlformats.org/drawingml/2006/main">
+            <a:r>
+              <a:t>Verification source: GasFree provider status + Nile Solidity RPC.</a:t>
+            </a:r>
+          </a:p>
+          <a:p xmlns:a="http://schemas.openxmlformats.org/drawingml/2006/main">
+            <a:r>
+              <a:t>GasFree API source: https://docs.gasfree.io/</a:t>
+            </a:r>
+          </a:p>
+          <a:p xmlns:a="http://schemas.openxmlformats.org/drawingml/2006/main">
+            <a:r>
+              <a:t>TRON Solidity confirmation source: https://developers.tron.network/docs/confirmation-semantics</a:t>
+            </a:r>
+          </a:p>
+          <a:p xmlns:a="http://schemas.openxmlformats.org/drawingml/2006/main">
+            <a:r>
+              <a:t>Nile Solidity receipt endpoint: https://nile.trongrid.io/walletsolidity/gettransactioninfobyid (POST)</a:t>
+            </a:r>
+          </a:p>
+          <a:p xmlns:a="http://schemas.openxmlformats.org/drawingml/2006/main">
+            <a:r>
+              <a:t>Scope boundary: this proves one recipient canary only, not the complete multi-recipient batch.</a:t>
+            </a:r>
+          </a:p>
+          <a:p xmlns:a="http://schemas.openxmlformats.org/drawingml/2006/main">
+            <a:r>
+              <a:t>Claims describe product scope; no market-size estimate is asserted.</a:t>
             </a:r>
           </a:p>
           <a:p xmlns:a="http://schemas.openxmlformats.org/drawingml/2006/main">
@@ -743,17 +828,47 @@
           </a:p>
           <a:p xmlns:a="http://schemas.openxmlformats.org/drawingml/2006/main">
             <a:r>
-              <a:t>Repository sources: projects/tron-c/README.md; projects/tron-c/docs/verification.md; projects/tron-c/server/README.md.</a:t>
-            </a:r>
-          </a:p>
-          <a:p xmlns:a="http://schemas.openxmlformats.org/drawingml/2006/main">
-            <a:r>
-              <a:t>Official GasFree integration references are linked from the repository README.</a:t>
-            </a:r>
-          </a:p>
-          <a:p xmlns:a="http://schemas.openxmlformats.org/drawingml/2006/main">
-            <a:r>
-              <a:t>Transaction link: unavailable — no GasFree credentials, traceId or verified Nile transaction exists yet.</a:t>
+              <a:t>Repository sources: projects/tron-c/docs/gasfree-one-shot.md; projects/tron-c/server/integration/README.md; sanitized canary evidence at submissions/gwdc-2026-settlemap/.data/gasfree-one-shot/gwdc-final-20260930-001.evidence.json.</a:t>
+            </a:r>
+          </a:p>
+          <a:p xmlns:a="http://schemas.openxmlformats.org/drawingml/2006/main">
+            <a:r>
+              <a:t>Verified Nile canary transaction: https://nile.tronscan.org/#/transaction/1f3a3de905eeef90570bf297bb592d4ac16383a5a10c1187c4e09b41b5fdd586</a:t>
+            </a:r>
+          </a:p>
+          <a:p xmlns:a="http://schemas.openxmlformats.org/drawingml/2006/main">
+            <a:r>
+              <a:t>Canary result: provider SUCCEED; chain SOLIDITY; block 71389721; exact TRC-20 Transfer at log index 2.</a:t>
+            </a:r>
+          </a:p>
+          <a:p xmlns:a="http://schemas.openxmlformats.org/drawingml/2006/main">
+            <a:r>
+              <a:t>Transfer: 1.000001 USDT from derived GasFree account TH3V9cnUct542ss5ZgAzNHWnFH9ycB1Tw1 to dedicated EOA TQcxtc1CmGRL8NwuDs3LewTBFycgXb28AR. Actual fee: 1.3 USDT.</a:t>
+            </a:r>
+          </a:p>
+          <a:p xmlns:a="http://schemas.openxmlformats.org/drawingml/2006/main">
+            <a:r>
+              <a:t>Verification source: GasFree provider status + Nile Solidity RPC.</a:t>
+            </a:r>
+          </a:p>
+          <a:p xmlns:a="http://schemas.openxmlformats.org/drawingml/2006/main">
+            <a:r>
+              <a:t>GasFree API source: https://docs.gasfree.io/</a:t>
+            </a:r>
+          </a:p>
+          <a:p xmlns:a="http://schemas.openxmlformats.org/drawingml/2006/main">
+            <a:r>
+              <a:t>TRON Solidity confirmation source: https://developers.tron.network/docs/confirmation-semantics</a:t>
+            </a:r>
+          </a:p>
+          <a:p xmlns:a="http://schemas.openxmlformats.org/drawingml/2006/main">
+            <a:r>
+              <a:t>Nile Solidity receipt endpoint: https://nile.trongrid.io/walletsolidity/gettransactioninfobyid (POST)</a:t>
+            </a:r>
+          </a:p>
+          <a:p xmlns:a="http://schemas.openxmlformats.org/drawingml/2006/main">
+            <a:r>
+              <a:t>Scope boundary: this proves one recipient canary only, not the complete multi-recipient batch.</a:t>
             </a:r>
           </a:p>
           <a:p xmlns:a="http://schemas.openxmlformats.org/drawingml/2006/main">
@@ -833,32 +948,57 @@
           <a:lstStyle xmlns:a="http://schemas.openxmlformats.org/drawingml/2006/main"/>
           <a:p xmlns:a="http://schemas.openxmlformats.org/drawingml/2006/main">
             <a:r>
-              <a:t>Slide 5 — Technical architecture and evidence.</a:t>
-            </a:r>
-          </a:p>
-          <a:p xmlns:a="http://schemas.openxmlformats.org/drawingml/2006/main">
-            <a:r>
-              <a:t>Repository sources: projects/tron-c/README.md; projects/tron-c/docs/verification.md; projects/tron-c/server/README.md.</a:t>
-            </a:r>
-          </a:p>
-          <a:p xmlns:a="http://schemas.openxmlformats.org/drawingml/2006/main">
-            <a:r>
-              <a:t>Official GasFree integration references are linked from the repository README.</a:t>
-            </a:r>
-          </a:p>
-          <a:p xmlns:a="http://schemas.openxmlformats.org/drawingml/2006/main">
-            <a:r>
-              <a:t>Transaction link: unavailable — no GasFree credentials, traceId or verified Nile transaction exists yet.</a:t>
+              <a:t>Slide 5 — Technical architecture and verified canary evidence.</a:t>
+            </a:r>
+          </a:p>
+          <a:p xmlns:a="http://schemas.openxmlformats.org/drawingml/2006/main">
+            <a:r>
+              <a:t>Repository sources: projects/tron-c/docs/gasfree-one-shot.md; projects/tron-c/server/integration/README.md; sanitized canary evidence at submissions/gwdc-2026-settlemap/.data/gasfree-one-shot/gwdc-final-20260930-001.evidence.json.</a:t>
+            </a:r>
+          </a:p>
+          <a:p xmlns:a="http://schemas.openxmlformats.org/drawingml/2006/main">
+            <a:r>
+              <a:t>Verified Nile canary transaction: https://nile.tronscan.org/#/transaction/1f3a3de905eeef90570bf297bb592d4ac16383a5a10c1187c4e09b41b5fdd586</a:t>
+            </a:r>
+          </a:p>
+          <a:p xmlns:a="http://schemas.openxmlformats.org/drawingml/2006/main">
+            <a:r>
+              <a:t>Canary result: provider SUCCEED; chain SOLIDITY; block 71389721; exact TRC-20 Transfer at log index 2.</a:t>
+            </a:r>
+          </a:p>
+          <a:p xmlns:a="http://schemas.openxmlformats.org/drawingml/2006/main">
+            <a:r>
+              <a:t>Transfer: 1.000001 USDT from derived GasFree account TH3V9cnUct542ss5ZgAzNHWnFH9ycB1Tw1 to dedicated EOA TQcxtc1CmGRL8NwuDs3LewTBFycgXb28AR. Actual fee: 1.3 USDT.</a:t>
+            </a:r>
+          </a:p>
+          <a:p xmlns:a="http://schemas.openxmlformats.org/drawingml/2006/main">
+            <a:r>
+              <a:t>Verification source: GasFree provider status + Nile Solidity RPC.</a:t>
+            </a:r>
+          </a:p>
+          <a:p xmlns:a="http://schemas.openxmlformats.org/drawingml/2006/main">
+            <a:r>
+              <a:t>GasFree API source: https://docs.gasfree.io/</a:t>
+            </a:r>
+          </a:p>
+          <a:p xmlns:a="http://schemas.openxmlformats.org/drawingml/2006/main">
+            <a:r>
+              <a:t>TRON Solidity confirmation source: https://developers.tron.network/docs/confirmation-semantics</a:t>
+            </a:r>
+          </a:p>
+          <a:p xmlns:a="http://schemas.openxmlformats.org/drawingml/2006/main">
+            <a:r>
+              <a:t>Nile Solidity receipt endpoint: https://nile.trongrid.io/walletsolidity/gettransactioninfobyid (POST)</a:t>
+            </a:r>
+          </a:p>
+          <a:p xmlns:a="http://schemas.openxmlformats.org/drawingml/2006/main">
+            <a:r>
+              <a:t>Scope boundary: this proves one recipient canary only, not the complete multi-recipient batch.</a:t>
             </a:r>
           </a:p>
           <a:p xmlns:a="http://schemas.openxmlformats.org/drawingml/2006/main">
             <a:r>
               <a:t>Screenshot: projects/tron-c/docs/verification-live-ui.png</a:t>
-            </a:r>
-          </a:p>
-          <a:p xmlns:a="http://schemas.openxmlformats.org/drawingml/2006/main">
-            <a:r>
-              <a:t>Evidence status: LIVE PROOF PENDING — No GasFree credential · traceId · tx hash · Nile receipt</a:t>
             </a:r>
           </a:p>
           <a:p xmlns:a="http://schemas.openxmlformats.org/drawingml/2006/main">
@@ -938,17 +1078,47 @@
           </a:p>
           <a:p xmlns:a="http://schemas.openxmlformats.org/drawingml/2006/main">
             <a:r>
-              <a:t>Repository sources: projects/tron-c/README.md; projects/tron-c/docs/verification.md; projects/tron-c/server/README.md.</a:t>
-            </a:r>
-          </a:p>
-          <a:p xmlns:a="http://schemas.openxmlformats.org/drawingml/2006/main">
-            <a:r>
-              <a:t>Official GasFree integration references are linked from the repository README.</a:t>
-            </a:r>
-          </a:p>
-          <a:p xmlns:a="http://schemas.openxmlformats.org/drawingml/2006/main">
-            <a:r>
-              <a:t>Transaction link: unavailable — no GasFree credentials, traceId or verified Nile transaction exists yet.</a:t>
+              <a:t>Repository sources: projects/tron-c/docs/gasfree-one-shot.md; projects/tron-c/server/integration/README.md; sanitized canary evidence at submissions/gwdc-2026-settlemap/.data/gasfree-one-shot/gwdc-final-20260930-001.evidence.json.</a:t>
+            </a:r>
+          </a:p>
+          <a:p xmlns:a="http://schemas.openxmlformats.org/drawingml/2006/main">
+            <a:r>
+              <a:t>Verified Nile canary transaction: https://nile.tronscan.org/#/transaction/1f3a3de905eeef90570bf297bb592d4ac16383a5a10c1187c4e09b41b5fdd586</a:t>
+            </a:r>
+          </a:p>
+          <a:p xmlns:a="http://schemas.openxmlformats.org/drawingml/2006/main">
+            <a:r>
+              <a:t>Canary result: provider SUCCEED; chain SOLIDITY; block 71389721; exact TRC-20 Transfer at log index 2.</a:t>
+            </a:r>
+          </a:p>
+          <a:p xmlns:a="http://schemas.openxmlformats.org/drawingml/2006/main">
+            <a:r>
+              <a:t>Transfer: 1.000001 USDT from derived GasFree account TH3V9cnUct542ss5ZgAzNHWnFH9ycB1Tw1 to dedicated EOA TQcxtc1CmGRL8NwuDs3LewTBFycgXb28AR. Actual fee: 1.3 USDT.</a:t>
+            </a:r>
+          </a:p>
+          <a:p xmlns:a="http://schemas.openxmlformats.org/drawingml/2006/main">
+            <a:r>
+              <a:t>Verification source: GasFree provider status + Nile Solidity RPC.</a:t>
+            </a:r>
+          </a:p>
+          <a:p xmlns:a="http://schemas.openxmlformats.org/drawingml/2006/main">
+            <a:r>
+              <a:t>GasFree API source: https://docs.gasfree.io/</a:t>
+            </a:r>
+          </a:p>
+          <a:p xmlns:a="http://schemas.openxmlformats.org/drawingml/2006/main">
+            <a:r>
+              <a:t>TRON Solidity confirmation source: https://developers.tron.network/docs/confirmation-semantics</a:t>
+            </a:r>
+          </a:p>
+          <a:p xmlns:a="http://schemas.openxmlformats.org/drawingml/2006/main">
+            <a:r>
+              <a:t>Nile Solidity receipt endpoint: https://nile.trongrid.io/walletsolidity/gettransactioninfobyid (POST)</a:t>
+            </a:r>
+          </a:p>
+          <a:p xmlns:a="http://schemas.openxmlformats.org/drawingml/2006/main">
+            <a:r>
+              <a:t>Scope boundary: this proves one recipient canary only, not the complete multi-recipient batch.</a:t>
             </a:r>
           </a:p>
           <a:p xmlns:a="http://schemas.openxmlformats.org/drawingml/2006/main">
@@ -1033,22 +1203,52 @@
           </a:p>
           <a:p xmlns:a="http://schemas.openxmlformats.org/drawingml/2006/main">
             <a:r>
-              <a:t>Repository sources: projects/tron-c/README.md; projects/tron-c/docs/verification.md; projects/tron-c/server/README.md.</a:t>
-            </a:r>
-          </a:p>
-          <a:p xmlns:a="http://schemas.openxmlformats.org/drawingml/2006/main">
-            <a:r>
-              <a:t>Official GasFree integration references are linked from the repository README.</a:t>
-            </a:r>
-          </a:p>
-          <a:p xmlns:a="http://schemas.openxmlformats.org/drawingml/2006/main">
-            <a:r>
-              <a:t>Transaction link: unavailable — no GasFree credentials, traceId or verified Nile transaction exists yet.</a:t>
-            </a:r>
-          </a:p>
-          <a:p xmlns:a="http://schemas.openxmlformats.org/drawingml/2006/main">
-            <a:r>
-              <a:t>Boundary: Today: integration path + robust fixture. No real GasFree transaction evidence yet.</a:t>
+              <a:t>Repository sources: projects/tron-c/docs/gasfree-one-shot.md; projects/tron-c/server/integration/README.md; sanitized canary evidence at submissions/gwdc-2026-settlemap/.data/gasfree-one-shot/gwdc-final-20260930-001.evidence.json.</a:t>
+            </a:r>
+          </a:p>
+          <a:p xmlns:a="http://schemas.openxmlformats.org/drawingml/2006/main">
+            <a:r>
+              <a:t>Verified Nile canary transaction: https://nile.tronscan.org/#/transaction/1f3a3de905eeef90570bf297bb592d4ac16383a5a10c1187c4e09b41b5fdd586</a:t>
+            </a:r>
+          </a:p>
+          <a:p xmlns:a="http://schemas.openxmlformats.org/drawingml/2006/main">
+            <a:r>
+              <a:t>Canary result: provider SUCCEED; chain SOLIDITY; block 71389721; exact TRC-20 Transfer at log index 2.</a:t>
+            </a:r>
+          </a:p>
+          <a:p xmlns:a="http://schemas.openxmlformats.org/drawingml/2006/main">
+            <a:r>
+              <a:t>Transfer: 1.000001 USDT from derived GasFree account TH3V9cnUct542ss5ZgAzNHWnFH9ycB1Tw1 to dedicated EOA TQcxtc1CmGRL8NwuDs3LewTBFycgXb28AR. Actual fee: 1.3 USDT.</a:t>
+            </a:r>
+          </a:p>
+          <a:p xmlns:a="http://schemas.openxmlformats.org/drawingml/2006/main">
+            <a:r>
+              <a:t>Verification source: GasFree provider status + Nile Solidity RPC.</a:t>
+            </a:r>
+          </a:p>
+          <a:p xmlns:a="http://schemas.openxmlformats.org/drawingml/2006/main">
+            <a:r>
+              <a:t>GasFree API source: https://docs.gasfree.io/</a:t>
+            </a:r>
+          </a:p>
+          <a:p xmlns:a="http://schemas.openxmlformats.org/drawingml/2006/main">
+            <a:r>
+              <a:t>TRON Solidity confirmation source: https://developers.tron.network/docs/confirmation-semantics</a:t>
+            </a:r>
+          </a:p>
+          <a:p xmlns:a="http://schemas.openxmlformats.org/drawingml/2006/main">
+            <a:r>
+              <a:t>Nile Solidity receipt endpoint: https://nile.trongrid.io/walletsolidity/gettransactioninfobyid (POST)</a:t>
+            </a:r>
+          </a:p>
+          <a:p xmlns:a="http://schemas.openxmlformats.org/drawingml/2006/main">
+            <a:r>
+              <a:t>Scope boundary: this proves one recipient canary only, not the complete multi-recipient batch.</a:t>
+            </a:r>
+          </a:p>
+          <a:p xmlns:a="http://schemas.openxmlformats.org/drawingml/2006/main">
+            <a:r>
+              <a:t>Next evidence milestone: a controlled multi-recipient Nile batch with live UI receipt capture.</a:t>
             </a:r>
           </a:p>
           <a:p xmlns:a="http://schemas.openxmlformats.org/drawingml/2006/main">
@@ -1121,7 +1321,7 @@
   </p:cSld>
   <p:clrMap bg1="lt1" tx1="dk1" bg2="lt2" tx2="dk2" accent1="accent1" accent2="accent2" accent3="accent3" accent4="accent4" accent5="accent5" accent6="accent6" hlink="hlink" folHlink="folHlink"/>
   <p:sldLayoutIdLst>
-    <p:sldLayoutId xmlns:r="http://schemas.openxmlformats.org/officeDocument/2006/relationships" id="2147483649" r:id="R2b41a02eb550496c"/>
+    <p:sldLayoutId xmlns:r="http://schemas.openxmlformats.org/officeDocument/2006/relationships" id="2147483649" r:id="Reebcd324a166452e"/>
   </p:sldLayoutIdLst>
   <p:txStyles>
     <p:titleStyle>
@@ -2128,14 +2328,14 @@
       </p:sp>
       <p:pic>
         <p:nvPicPr>
-          <p:cNvPr id="21" name=""/>
+          <p:cNvPr id="23" name=""/>
           <p:cNvPicPr>
             <a:picLocks xmlns:a="http://schemas.openxmlformats.org/drawingml/2006/main" noChangeAspect="1"/>
           </p:cNvPicPr>
           <p:nvPr/>
         </p:nvPicPr>
         <p:blipFill>
-          <a:blip xmlns:r="http://schemas.openxmlformats.org/officeDocument/2006/relationships" xmlns:a="http://schemas.openxmlformats.org/drawingml/2006/main" r:embed="R6ff52195e4974de0"/>
+          <a:blip xmlns:r="http://schemas.openxmlformats.org/officeDocument/2006/relationships" xmlns:a="http://schemas.openxmlformats.org/drawingml/2006/main" r:embed="R490c8ea8837a4776"/>
           <a:srcRect xmlns:a="http://schemas.openxmlformats.org/drawingml/2006/main" l="4000" t="2000" r="1000" b="2000"/>
           <a:stretch xmlns:a="http://schemas.openxmlformats.org/drawingml/2006/main"/>
         </p:blipFill>
@@ -2702,14 +2902,14 @@
       </p:sp>
       <p:pic>
         <p:nvPicPr>
-          <p:cNvPr id="33" name=""/>
+          <p:cNvPr id="35" name=""/>
           <p:cNvPicPr>
             <a:picLocks xmlns:a="http://schemas.openxmlformats.org/drawingml/2006/main" noChangeAspect="1"/>
           </p:cNvPicPr>
           <p:nvPr/>
         </p:nvPicPr>
         <p:blipFill>
-          <a:blip xmlns:r="http://schemas.openxmlformats.org/officeDocument/2006/relationships" xmlns:a="http://schemas.openxmlformats.org/drawingml/2006/main" r:embed="Rd71e1e6edf654a42"/>
+          <a:blip xmlns:r="http://schemas.openxmlformats.org/officeDocument/2006/relationships" xmlns:a="http://schemas.openxmlformats.org/drawingml/2006/main" r:embed="R0fc8baa22ed649cf"/>
           <a:srcRect xmlns:a="http://schemas.openxmlformats.org/drawingml/2006/main" l="3000" t="0" r="1000" b="0"/>
           <a:stretch xmlns:a="http://schemas.openxmlformats.org/drawingml/2006/main"/>
         </p:blipFill>
@@ -3333,7 +3533,7 @@
                 <a:ea typeface="Helvetica Neue"/>
                 <a:cs typeface="Helvetica Neue"/>
               </a:rPr>
-              <a:t>BOUNDARY</a:t>
+              <a:t>VERIFIED SCOPE</a:t>
             </a:r>
           </a:p>
         </p:txBody>
@@ -3394,7 +3594,7 @@
                 <a:ea typeface="Helvetica Neue"/>
                 <a:cs typeface="Helvetica Neue"/>
               </a:rPr>
-              <a:t>No real GasFree credentials, trace or transaction has been verified. Current execution evidence is fixture-only.</a:t>
+              <a:t>Verified Nile canary: 1.000001 USDT from derived GasFree account to dedicated EOA. Actual fee: 1.3 USDT.</a:t>
             </a:r>
           </a:p>
         </p:txBody>
@@ -5392,14 +5592,14 @@
       </p:sp>
       <p:pic>
         <p:nvPicPr>
-          <p:cNvPr id="37" name=""/>
+          <p:cNvPr id="39" name=""/>
           <p:cNvPicPr>
             <a:picLocks xmlns:a="http://schemas.openxmlformats.org/drawingml/2006/main" noChangeAspect="1"/>
           </p:cNvPicPr>
           <p:nvPr/>
         </p:nvPicPr>
         <p:blipFill>
-          <a:blip xmlns:r="http://schemas.openxmlformats.org/officeDocument/2006/relationships" xmlns:a="http://schemas.openxmlformats.org/drawingml/2006/main" r:embed="Re61e2fdd9ae74b3a"/>
+          <a:blip xmlns:r="http://schemas.openxmlformats.org/officeDocument/2006/relationships" xmlns:a="http://schemas.openxmlformats.org/drawingml/2006/main" r:embed="R753b635954c04ef4"/>
           <a:srcRect xmlns:a="http://schemas.openxmlformats.org/drawingml/2006/main" l="3000" t="0" r="1000" b="0"/>
           <a:stretch xmlns:a="http://schemas.openxmlformats.org/drawingml/2006/main"/>
         </p:blipFill>
@@ -6726,7 +6926,7 @@
                 <a:ea typeface="Helvetica Neue"/>
                 <a:cs typeface="Helvetica Neue"/>
               </a:rPr>
-              <a:t>The live path is wired—and still awaiting proof.</a:t>
+              <a:t>The live path now has a verified Nile canary.</a:t>
             </a:r>
           </a:p>
         </p:txBody>
@@ -6787,7 +6987,7 @@
                 <a:ea typeface="Helvetica Neue"/>
                 <a:cs typeface="Helvetica Neue"/>
               </a:rPr>
-              <a:t>A compact architecture makes every trust boundary visible.</a:t>
+              <a:t>GasFree provider status and Nile Solidity RPC agree on the exact TRC-20 Transfer.</a:t>
             </a:r>
           </a:p>
         </p:txBody>
@@ -7813,7 +8013,7 @@
                 <a:ea typeface="Helvetica Neue"/>
                 <a:cs typeface="Helvetica Neue"/>
               </a:rPr>
-              <a:t>Two CSVs plus a checksum manifest preserve row-to-payment reconciliation.</a:t>
+              <a:t>Exact token, sender, receiver and 1.000001 USDT matched at log index 2.</a:t>
             </a:r>
           </a:p>
         </p:txBody>
@@ -7852,14 +8052,14 @@
       </p:sp>
       <p:pic>
         <p:nvPicPr>
-          <p:cNvPr id="61" name=""/>
+          <p:cNvPr id="63" name=""/>
           <p:cNvPicPr>
             <a:picLocks xmlns:a="http://schemas.openxmlformats.org/drawingml/2006/main" noChangeAspect="1"/>
           </p:cNvPicPr>
           <p:nvPr/>
         </p:nvPicPr>
         <p:blipFill>
-          <a:blip xmlns:r="http://schemas.openxmlformats.org/officeDocument/2006/relationships" xmlns:a="http://schemas.openxmlformats.org/drawingml/2006/main" r:embed="R7c47d92c8836433b"/>
+          <a:blip xmlns:r="http://schemas.openxmlformats.org/officeDocument/2006/relationships" xmlns:a="http://schemas.openxmlformats.org/drawingml/2006/main" r:embed="R08468fc36e624dbc"/>
           <a:srcRect xmlns:a="http://schemas.openxmlformats.org/drawingml/2006/main" l="0" t="5000" r="0" b="72000"/>
           <a:stretch xmlns:a="http://schemas.openxmlformats.org/drawingml/2006/main"/>
         </p:blipFill>
@@ -7963,7 +8163,7 @@
                 <a:ea typeface="Helvetica Neue"/>
                 <a:cs typeface="Helvetica Neue"/>
               </a:rPr>
-              <a:t>LIVE PROOF PENDING</a:t>
+              <a:t>ONE-RECIPIENT CANARY VERIFIED</a:t>
             </a:r>
           </a:p>
         </p:txBody>
@@ -8024,7 +8224,7 @@
                 <a:ea typeface="Helvetica Neue"/>
                 <a:cs typeface="Helvetica Neue"/>
               </a:rPr>
-              <a:t>No GasFree credential · traceId · tx hash · Nile receipt</a:t>
+              <a:t>SUCCEED · SOLIDITY · block 71389721 · log 2</a:t>
             </a:r>
           </a:p>
         </p:txBody>
@@ -10395,7 +10595,7 @@
                 <a:ea typeface="Helvetica Neue"/>
                 <a:cs typeface="Helvetica Neue"/>
               </a:rPr>
-              <a:t>Ship the missing proof, then scale.</a:t>
+              <a:t>One verified canary. Full batch proof comes next.</a:t>
             </a:r>
           </a:p>
         </p:txBody>
@@ -10456,7 +10656,7 @@
                 <a:ea typeface="Helvetica Neue"/>
                 <a:cs typeface="Helvetica Neue"/>
               </a:rPr>
-              <a:t>The next milestone closes the current evidence gap before expanding product scope.</a:t>
+              <a:t>The Nile write path now has real evidence. Multi-recipient execution remains unproven.</a:t>
             </a:r>
           </a:p>
         </p:txBody>
@@ -10613,7 +10813,7 @@
                 <a:ea typeface="Helvetica Neue"/>
                 <a:cs typeface="Helvetica Neue"/>
               </a:rPr>
-              <a:t>WORKING PROTOTYPE</a:t>
+              <a:t>VERIFIED EVIDENCE</a:t>
             </a:r>
           </a:p>
         </p:txBody>
@@ -10857,7 +11057,7 @@
                 <a:ea typeface="Helvetica Neue"/>
                 <a:cs typeface="Helvetica Neue"/>
               </a:rPr>
-              <a:t>UNKNOWN-safe recovery</a:t>
+              <a:t>One-recipient Nile canary</a:t>
             </a:r>
           </a:p>
         </p:txBody>
@@ -10979,7 +11179,7 @@
                 <a:ea typeface="Helvetica Neue"/>
                 <a:cs typeface="Helvetica Neue"/>
               </a:rPr>
-              <a:t>Two-level reconciliation</a:t>
+              <a:t>Exact Transfer at log 2</a:t>
             </a:r>
           </a:p>
         </p:txBody>
@@ -11136,7 +11336,7 @@
                 <a:ea typeface="Helvetica Neue"/>
                 <a:cs typeface="Helvetica Neue"/>
               </a:rPr>
-              <a:t>EVIDENCE MILESTONE</a:t>
+              <a:t>CONTROLLED EXPANSION</a:t>
             </a:r>
           </a:p>
         </p:txBody>
@@ -11258,7 +11458,7 @@
                 <a:ea typeface="Helvetica Neue"/>
                 <a:cs typeface="Helvetica Neue"/>
               </a:rPr>
-              <a:t>GasFree Nile credentials</a:t>
+              <a:t>Multi-recipient Nile batch</a:t>
             </a:r>
           </a:p>
         </p:txBody>
@@ -11380,7 +11580,7 @@
                 <a:ea typeface="Helvetica Neue"/>
                 <a:cs typeface="Helvetica Neue"/>
               </a:rPr>
-              <a:t>TronLink TIP-712 acceptance</a:t>
+              <a:t>Live UI receipt capture</a:t>
             </a:r>
           </a:p>
         </p:txBody>
@@ -11502,7 +11702,7 @@
                 <a:ea typeface="Helvetica Neue"/>
                 <a:cs typeface="Helvetica Neue"/>
               </a:rPr>
-              <a:t>Small-value live receipt</a:t>
+              <a:t>Recovery drill on real trace</a:t>
             </a:r>
           </a:p>
         </p:txBody>
@@ -12179,7 +12379,7 @@
                 <a:ea typeface="Helvetica Neue"/>
                 <a:cs typeface="Helvetica Neue"/>
               </a:rPr>
-              <a:t>Today: integration path + robust fixture. No real GasFree transaction evidence yet.</a:t>
+              <a:t>Verified: 1 recipient, 1.000001 USDT, 1.3 USDT fee. Full batch remains unproven.</a:t>
             </a:r>
           </a:p>
         </p:txBody>

</xml_diff>